<commit_message>
feat: add lactation group presets to ration studio and update developer 24/7 monitoring notice
</commit_message>
<xml_diff>
--- a/public/MilkIQ_Tanitim_Sunumu.pptx
+++ b/public/MilkIQ_Tanitim_Sunumu.pptx
@@ -2645,7 +2645,7 @@
                 <a:ea typeface="Segoe UI" pitchFamily="34" charset="-122"/>
                 <a:cs typeface="Segoe UI" pitchFamily="34" charset="-120"/>
               </a:rPr>
-              <a:t>Destek &amp; İletişim: erkanerdem8254@gmail.com</a:t>
+              <a:t>7/24 Kesintisiz Geliştirici Takibi &amp; Teknik Destek</a:t>
             </a:r>
             <a:endParaRPr lang="en-US" sz="1100" dirty="0"/>
           </a:p>
@@ -9066,7 +9066,7 @@
                 <a:ea typeface="Segoe UI" pitchFamily="34" charset="-122"/>
                 <a:cs typeface="Segoe UI" pitchFamily="34" charset="-120"/>
               </a:rPr>
-              <a:t>• Doğrudan yetkili e-posta adresine detaylı hata raporu.</a:t>
+              <a:t>• Geliştirici Erkan Erdem'e hata detayları anında iletilir (7/24 Takip).</a:t>
             </a:r>
             <a:endParaRPr lang="en-US" sz="1050" dirty="0"/>
           </a:p>

</xml_diff>